<commit_message>
all-slides-with-answers.pdf all-slides.pdf exam.pdf exam.pptx modules.pdf modules.pptx
</commit_message>
<xml_diff>
--- a/ipsa/slides/exam.pptx
+++ b/ipsa/slides/exam.pptx
@@ -5,14 +5,15 @@
     <p:sldMasterId id="2147483648" r:id="rId1"/>
   </p:sldMasterIdLst>
   <p:notesMasterIdLst>
-    <p:notesMasterId r:id="rId7"/>
+    <p:notesMasterId r:id="rId8"/>
   </p:notesMasterIdLst>
   <p:sldIdLst>
     <p:sldId id="475" r:id="rId2"/>
     <p:sldId id="703" r:id="rId3"/>
     <p:sldId id="705" r:id="rId4"/>
-    <p:sldId id="707" r:id="rId5"/>
-    <p:sldId id="708" r:id="rId6"/>
+    <p:sldId id="709" r:id="rId5"/>
+    <p:sldId id="707" r:id="rId6"/>
+    <p:sldId id="708" r:id="rId7"/>
   </p:sldIdLst>
   <p:sldSz cx="12192000" cy="6858000"/>
   <p:notesSz cx="6858000" cy="9144000"/>
@@ -119,38 +120,31 @@
 </p:presentation>
 </file>
 
+<file path=ppt/revisionInfo.xml><?xml version="1.0" encoding="utf-8"?>
+<p1510:revInfo xmlns:a="http://schemas.openxmlformats.org/drawingml/2006/main" xmlns:r="http://schemas.openxmlformats.org/officeDocument/2006/relationships" xmlns:p1510="http://schemas.microsoft.com/office/powerpoint/2015/10/main">
+  <p1510:revLst>
+    <p1510:client id="{5DFB3D16-2569-4EDF-8550-749E41FF543D}" v="339" dt="2026-04-20T12:50:23.058"/>
+  </p1510:revLst>
+</p1510:revInfo>
+</file>
+
 <file path=ppt/changesInfos/changesInfo1.xml><?xml version="1.0" encoding="utf-8"?>
 <pc:chgInfo xmlns:a="http://schemas.openxmlformats.org/drawingml/2006/main" xmlns:r="http://schemas.openxmlformats.org/officeDocument/2006/relationships" xmlns:ac="http://schemas.microsoft.com/office/drawing/2013/main/command" xmlns:pc="http://schemas.microsoft.com/office/powerpoint/2013/main/command">
   <pc:docChgLst>
-    <pc:chgData name="Gerth Stølting Brodal" userId="04ef4784-6591-4f86-a140-f5c3b108582a" providerId="ADAL" clId="{EE2C17C0-1D70-424E-A6AD-F76FBCBC6F35}"/>
-    <pc:docChg chg="modSld">
-      <pc:chgData name="Gerth Stølting Brodal" userId="04ef4784-6591-4f86-a140-f5c3b108582a" providerId="ADAL" clId="{EE2C17C0-1D70-424E-A6AD-F76FBCBC6F35}" dt="2026-01-24T00:01:39.536" v="81" actId="1036"/>
+    <pc:chgData name="Gerth Stølting Brodal" userId="04ef4784-6591-4f86-a140-f5c3b108582a" providerId="ADAL" clId="{73BAC7D6-516A-44B5-B4B0-C7B08CA8B392}"/>
+    <pc:docChg chg="undo custSel addSld modSld">
+      <pc:chgData name="Gerth Stølting Brodal" userId="04ef4784-6591-4f86-a140-f5c3b108582a" providerId="ADAL" clId="{73BAC7D6-516A-44B5-B4B0-C7B08CA8B392}" dt="2026-04-20T12:50:33.999" v="765" actId="1076"/>
       <pc:docMkLst>
         <pc:docMk/>
       </pc:docMkLst>
       <pc:sldChg chg="modSp mod">
-        <pc:chgData name="Gerth Stølting Brodal" userId="04ef4784-6591-4f86-a140-f5c3b108582a" providerId="ADAL" clId="{EE2C17C0-1D70-424E-A6AD-F76FBCBC6F35}" dt="2026-01-23T23:58:03.534" v="13" actId="20577"/>
-        <pc:sldMkLst>
-          <pc:docMk/>
-          <pc:sldMk cId="1038163257" sldId="475"/>
-        </pc:sldMkLst>
-        <pc:spChg chg="mod">
-          <ac:chgData name="Gerth Stølting Brodal" userId="04ef4784-6591-4f86-a140-f5c3b108582a" providerId="ADAL" clId="{EE2C17C0-1D70-424E-A6AD-F76FBCBC6F35}" dt="2026-01-23T23:58:03.534" v="13" actId="20577"/>
-          <ac:spMkLst>
-            <pc:docMk/>
-            <pc:sldMk cId="1038163257" sldId="475"/>
-            <ac:spMk id="3" creationId="{00000000-0000-0000-0000-000000000000}"/>
-          </ac:spMkLst>
-        </pc:spChg>
-      </pc:sldChg>
-      <pc:sldChg chg="modSp mod">
-        <pc:chgData name="Gerth Stølting Brodal" userId="04ef4784-6591-4f86-a140-f5c3b108582a" providerId="ADAL" clId="{EE2C17C0-1D70-424E-A6AD-F76FBCBC6F35}" dt="2026-01-23T23:58:40.959" v="31" actId="20577"/>
+        <pc:chgData name="Gerth Stølting Brodal" userId="04ef4784-6591-4f86-a140-f5c3b108582a" providerId="ADAL" clId="{73BAC7D6-516A-44B5-B4B0-C7B08CA8B392}" dt="2026-04-20T11:14:16.301" v="33" actId="20577"/>
         <pc:sldMkLst>
           <pc:docMk/>
           <pc:sldMk cId="1270503327" sldId="703"/>
         </pc:sldMkLst>
         <pc:spChg chg="mod">
-          <ac:chgData name="Gerth Stølting Brodal" userId="04ef4784-6591-4f86-a140-f5c3b108582a" providerId="ADAL" clId="{EE2C17C0-1D70-424E-A6AD-F76FBCBC6F35}" dt="2026-01-23T23:58:40.959" v="31" actId="20577"/>
+          <ac:chgData name="Gerth Stølting Brodal" userId="04ef4784-6591-4f86-a140-f5c3b108582a" providerId="ADAL" clId="{73BAC7D6-516A-44B5-B4B0-C7B08CA8B392}" dt="2026-04-20T11:14:16.301" v="33" actId="20577"/>
           <ac:spMkLst>
             <pc:docMk/>
             <pc:sldMk cId="1270503327" sldId="703"/>
@@ -158,20 +152,204 @@
           </ac:spMkLst>
         </pc:spChg>
       </pc:sldChg>
-      <pc:sldChg chg="modSp mod">
-        <pc:chgData name="Gerth Stølting Brodal" userId="04ef4784-6591-4f86-a140-f5c3b108582a" providerId="ADAL" clId="{EE2C17C0-1D70-424E-A6AD-F76FBCBC6F35}" dt="2026-01-24T00:01:39.536" v="81" actId="1036"/>
+      <pc:sldChg chg="addSp delSp modSp new mod delAnim modAnim modNotesTx">
+        <pc:chgData name="Gerth Stølting Brodal" userId="04ef4784-6591-4f86-a140-f5c3b108582a" providerId="ADAL" clId="{73BAC7D6-516A-44B5-B4B0-C7B08CA8B392}" dt="2026-04-20T12:50:33.999" v="765" actId="1076"/>
         <pc:sldMkLst>
           <pc:docMk/>
-          <pc:sldMk cId="519874080" sldId="707"/>
+          <pc:sldMk cId="1621346635" sldId="709"/>
         </pc:sldMkLst>
         <pc:spChg chg="mod">
-          <ac:chgData name="Gerth Stølting Brodal" userId="04ef4784-6591-4f86-a140-f5c3b108582a" providerId="ADAL" clId="{EE2C17C0-1D70-424E-A6AD-F76FBCBC6F35}" dt="2026-01-24T00:01:39.536" v="81" actId="1036"/>
+          <ac:chgData name="Gerth Stølting Brodal" userId="04ef4784-6591-4f86-a140-f5c3b108582a" providerId="ADAL" clId="{73BAC7D6-516A-44B5-B4B0-C7B08CA8B392}" dt="2026-04-20T12:29:35.321" v="673" actId="14100"/>
           <ac:spMkLst>
             <pc:docMk/>
-            <pc:sldMk cId="519874080" sldId="707"/>
-            <ac:spMk id="3" creationId="{00000000-0000-0000-0000-000000000000}"/>
+            <pc:sldMk cId="1621346635" sldId="709"/>
+            <ac:spMk id="2" creationId="{A4839964-8178-89B3-04C4-FDBFEA7CD89E}"/>
           </ac:spMkLst>
         </pc:spChg>
+        <pc:spChg chg="del mod">
+          <ac:chgData name="Gerth Stølting Brodal" userId="04ef4784-6591-4f86-a140-f5c3b108582a" providerId="ADAL" clId="{73BAC7D6-516A-44B5-B4B0-C7B08CA8B392}" dt="2026-04-20T12:34:51.062" v="729" actId="478"/>
+          <ac:spMkLst>
+            <pc:docMk/>
+            <pc:sldMk cId="1621346635" sldId="709"/>
+            <ac:spMk id="3" creationId="{6E750014-9145-E154-27EF-1D9E2AB19393}"/>
+          </ac:spMkLst>
+        </pc:spChg>
+        <pc:spChg chg="add del mod">
+          <ac:chgData name="Gerth Stølting Brodal" userId="04ef4784-6591-4f86-a140-f5c3b108582a" providerId="ADAL" clId="{73BAC7D6-516A-44B5-B4B0-C7B08CA8B392}" dt="2026-04-20T11:24:30.795" v="232" actId="478"/>
+          <ac:spMkLst>
+            <pc:docMk/>
+            <pc:sldMk cId="1621346635" sldId="709"/>
+            <ac:spMk id="7" creationId="{BA20E5B2-C0B8-B93C-AC0A-0C02482773D5}"/>
+          </ac:spMkLst>
+        </pc:spChg>
+        <pc:spChg chg="add mod">
+          <ac:chgData name="Gerth Stølting Brodal" userId="04ef4784-6591-4f86-a140-f5c3b108582a" providerId="ADAL" clId="{73BAC7D6-516A-44B5-B4B0-C7B08CA8B392}" dt="2026-04-20T12:43:05.989" v="762" actId="6549"/>
+          <ac:spMkLst>
+            <pc:docMk/>
+            <pc:sldMk cId="1621346635" sldId="709"/>
+            <ac:spMk id="10" creationId="{0A1E62CB-F7E9-1988-4B21-7A499DC0F6A3}"/>
+          </ac:spMkLst>
+        </pc:spChg>
+        <pc:spChg chg="add del mod">
+          <ac:chgData name="Gerth Stølting Brodal" userId="04ef4784-6591-4f86-a140-f5c3b108582a" providerId="ADAL" clId="{73BAC7D6-516A-44B5-B4B0-C7B08CA8B392}" dt="2026-04-20T11:24:29.716" v="231" actId="478"/>
+          <ac:spMkLst>
+            <pc:docMk/>
+            <pc:sldMk cId="1621346635" sldId="709"/>
+            <ac:spMk id="13" creationId="{8595C4BB-7CB7-5BE7-03FB-DD89DB98F0FF}"/>
+          </ac:spMkLst>
+        </pc:spChg>
+        <pc:spChg chg="add mod">
+          <ac:chgData name="Gerth Stølting Brodal" userId="04ef4784-6591-4f86-a140-f5c3b108582a" providerId="ADAL" clId="{73BAC7D6-516A-44B5-B4B0-C7B08CA8B392}" dt="2026-04-20T12:24:17.953" v="618" actId="1076"/>
+          <ac:spMkLst>
+            <pc:docMk/>
+            <pc:sldMk cId="1621346635" sldId="709"/>
+            <ac:spMk id="15" creationId="{79F44FD5-BCE3-076F-9F02-5A3789E615F4}"/>
+          </ac:spMkLst>
+        </pc:spChg>
+        <pc:spChg chg="add mod">
+          <ac:chgData name="Gerth Stølting Brodal" userId="04ef4784-6591-4f86-a140-f5c3b108582a" providerId="ADAL" clId="{73BAC7D6-516A-44B5-B4B0-C7B08CA8B392}" dt="2026-04-20T12:24:32.051" v="634" actId="1076"/>
+          <ac:spMkLst>
+            <pc:docMk/>
+            <pc:sldMk cId="1621346635" sldId="709"/>
+            <ac:spMk id="16" creationId="{C078C52F-5AE4-B055-8261-D7352360BB9A}"/>
+          </ac:spMkLst>
+        </pc:spChg>
+        <pc:spChg chg="add mod">
+          <ac:chgData name="Gerth Stølting Brodal" userId="04ef4784-6591-4f86-a140-f5c3b108582a" providerId="ADAL" clId="{73BAC7D6-516A-44B5-B4B0-C7B08CA8B392}" dt="2026-04-20T12:33:33.499" v="686" actId="20577"/>
+          <ac:spMkLst>
+            <pc:docMk/>
+            <pc:sldMk cId="1621346635" sldId="709"/>
+            <ac:spMk id="19" creationId="{EBCC6460-8B81-C7D8-944F-4BA9F694AD3A}"/>
+          </ac:spMkLst>
+        </pc:spChg>
+        <pc:spChg chg="add mod">
+          <ac:chgData name="Gerth Stølting Brodal" userId="04ef4784-6591-4f86-a140-f5c3b108582a" providerId="ADAL" clId="{73BAC7D6-516A-44B5-B4B0-C7B08CA8B392}" dt="2026-04-20T12:25:27.326" v="644" actId="1076"/>
+          <ac:spMkLst>
+            <pc:docMk/>
+            <pc:sldMk cId="1621346635" sldId="709"/>
+            <ac:spMk id="27" creationId="{F72ECF3C-3D78-F5CE-F77B-9377DE39CDB8}"/>
+          </ac:spMkLst>
+        </pc:spChg>
+        <pc:spChg chg="add mod">
+          <ac:chgData name="Gerth Stølting Brodal" userId="04ef4784-6591-4f86-a140-f5c3b108582a" providerId="ADAL" clId="{73BAC7D6-516A-44B5-B4B0-C7B08CA8B392}" dt="2026-04-20T12:44:15.928" v="763" actId="113"/>
+          <ac:spMkLst>
+            <pc:docMk/>
+            <pc:sldMk cId="1621346635" sldId="709"/>
+            <ac:spMk id="30" creationId="{2681E6CD-554F-8D3A-ED30-88D9D04981E2}"/>
+          </ac:spMkLst>
+        </pc:spChg>
+        <pc:spChg chg="add del mod">
+          <ac:chgData name="Gerth Stølting Brodal" userId="04ef4784-6591-4f86-a140-f5c3b108582a" providerId="ADAL" clId="{73BAC7D6-516A-44B5-B4B0-C7B08CA8B392}" dt="2026-04-20T12:34:56.341" v="730" actId="478"/>
+          <ac:spMkLst>
+            <pc:docMk/>
+            <pc:sldMk cId="1621346635" sldId="709"/>
+            <ac:spMk id="44" creationId="{39F6CAA4-1AA2-48F5-BEA7-256E8CFF95ED}"/>
+          </ac:spMkLst>
+        </pc:spChg>
+        <pc:picChg chg="add del mod">
+          <ac:chgData name="Gerth Stølting Brodal" userId="04ef4784-6591-4f86-a140-f5c3b108582a" providerId="ADAL" clId="{73BAC7D6-516A-44B5-B4B0-C7B08CA8B392}" dt="2026-04-20T11:29:23.833" v="340" actId="478"/>
+          <ac:picMkLst>
+            <pc:docMk/>
+            <pc:sldMk cId="1621346635" sldId="709"/>
+            <ac:picMk id="5" creationId="{7F1A4E26-681F-3085-14B6-9D06EFD1E981}"/>
+          </ac:picMkLst>
+        </pc:picChg>
+        <pc:picChg chg="add del mod ord">
+          <ac:chgData name="Gerth Stølting Brodal" userId="04ef4784-6591-4f86-a140-f5c3b108582a" providerId="ADAL" clId="{73BAC7D6-516A-44B5-B4B0-C7B08CA8B392}" dt="2026-04-20T11:29:59.550" v="347" actId="478"/>
+          <ac:picMkLst>
+            <pc:docMk/>
+            <pc:sldMk cId="1621346635" sldId="709"/>
+            <ac:picMk id="22" creationId="{185FF4AB-0754-696F-1FE5-71F9F5CE9F95}"/>
+          </ac:picMkLst>
+        </pc:picChg>
+        <pc:picChg chg="add del mod ord">
+          <ac:chgData name="Gerth Stølting Brodal" userId="04ef4784-6591-4f86-a140-f5c3b108582a" providerId="ADAL" clId="{73BAC7D6-516A-44B5-B4B0-C7B08CA8B392}" dt="2026-04-20T12:15:57.453" v="494" actId="478"/>
+          <ac:picMkLst>
+            <pc:docMk/>
+            <pc:sldMk cId="1621346635" sldId="709"/>
+            <ac:picMk id="24" creationId="{B068A8F1-C63F-3494-C38A-A2DA994029C3}"/>
+          </ac:picMkLst>
+        </pc:picChg>
+        <pc:picChg chg="add del mod ord">
+          <ac:chgData name="Gerth Stølting Brodal" userId="04ef4784-6591-4f86-a140-f5c3b108582a" providerId="ADAL" clId="{73BAC7D6-516A-44B5-B4B0-C7B08CA8B392}" dt="2026-04-20T12:23:43.232" v="560" actId="478"/>
+          <ac:picMkLst>
+            <pc:docMk/>
+            <pc:sldMk cId="1621346635" sldId="709"/>
+            <ac:picMk id="34" creationId="{6427C406-AFCC-A76F-9CCF-E89F5FEBAE20}"/>
+          </ac:picMkLst>
+        </pc:picChg>
+        <pc:picChg chg="add del mod ord">
+          <ac:chgData name="Gerth Stølting Brodal" userId="04ef4784-6591-4f86-a140-f5c3b108582a" providerId="ADAL" clId="{73BAC7D6-516A-44B5-B4B0-C7B08CA8B392}" dt="2026-04-20T12:29:07.389" v="650" actId="478"/>
+          <ac:picMkLst>
+            <pc:docMk/>
+            <pc:sldMk cId="1621346635" sldId="709"/>
+            <ac:picMk id="40" creationId="{C06F56C5-8911-EA7C-928E-08118F8E009B}"/>
+          </ac:picMkLst>
+        </pc:picChg>
+        <pc:picChg chg="add mod ord">
+          <ac:chgData name="Gerth Stølting Brodal" userId="04ef4784-6591-4f86-a140-f5c3b108582a" providerId="ADAL" clId="{73BAC7D6-516A-44B5-B4B0-C7B08CA8B392}" dt="2026-04-20T12:35:07.409" v="735" actId="1036"/>
+          <ac:picMkLst>
+            <pc:docMk/>
+            <pc:sldMk cId="1621346635" sldId="709"/>
+            <ac:picMk id="42" creationId="{422E1ED9-C2CA-2180-0933-AE9C3478D57A}"/>
+          </ac:picMkLst>
+        </pc:picChg>
+        <pc:picChg chg="add mod">
+          <ac:chgData name="Gerth Stølting Brodal" userId="04ef4784-6591-4f86-a140-f5c3b108582a" providerId="ADAL" clId="{73BAC7D6-516A-44B5-B4B0-C7B08CA8B392}" dt="2026-04-20T12:50:33.999" v="765" actId="1076"/>
+          <ac:picMkLst>
+            <pc:docMk/>
+            <pc:sldMk cId="1621346635" sldId="709"/>
+            <ac:picMk id="45" creationId="{5BE67AD2-6117-A31F-8C68-3E75AC60DEC6}"/>
+          </ac:picMkLst>
+        </pc:picChg>
+        <pc:cxnChg chg="add mod">
+          <ac:chgData name="Gerth Stølting Brodal" userId="04ef4784-6591-4f86-a140-f5c3b108582a" providerId="ADAL" clId="{73BAC7D6-516A-44B5-B4B0-C7B08CA8B392}" dt="2026-04-20T12:24:04.486" v="617" actId="1076"/>
+          <ac:cxnSpMkLst>
+            <pc:docMk/>
+            <pc:sldMk cId="1621346635" sldId="709"/>
+            <ac:cxnSpMk id="6" creationId="{A250C8EE-B57E-773A-A776-D344E124516D}"/>
+          </ac:cxnSpMkLst>
+        </pc:cxnChg>
+        <pc:cxnChg chg="add mod">
+          <ac:chgData name="Gerth Stølting Brodal" userId="04ef4784-6591-4f86-a140-f5c3b108582a" providerId="ADAL" clId="{73BAC7D6-516A-44B5-B4B0-C7B08CA8B392}" dt="2026-04-20T12:24:24.293" v="632" actId="1035"/>
+          <ac:cxnSpMkLst>
+            <pc:docMk/>
+            <pc:sldMk cId="1621346635" sldId="709"/>
+            <ac:cxnSpMk id="9" creationId="{A8117F7D-C276-8AE8-3E95-77E9E6528BC5}"/>
+          </ac:cxnSpMkLst>
+        </pc:cxnChg>
+        <pc:cxnChg chg="add mod">
+          <ac:chgData name="Gerth Stølting Brodal" userId="04ef4784-6591-4f86-a140-f5c3b108582a" providerId="ADAL" clId="{73BAC7D6-516A-44B5-B4B0-C7B08CA8B392}" dt="2026-04-20T12:23:50.671" v="576" actId="1035"/>
+          <ac:cxnSpMkLst>
+            <pc:docMk/>
+            <pc:sldMk cId="1621346635" sldId="709"/>
+            <ac:cxnSpMk id="12" creationId="{615B64E8-C9CB-2016-0FC3-88D66041AEC5}"/>
+          </ac:cxnSpMkLst>
+        </pc:cxnChg>
+        <pc:cxnChg chg="add mod">
+          <ac:chgData name="Gerth Stølting Brodal" userId="04ef4784-6591-4f86-a140-f5c3b108582a" providerId="ADAL" clId="{73BAC7D6-516A-44B5-B4B0-C7B08CA8B392}" dt="2026-04-20T12:24:17.953" v="618" actId="1076"/>
+          <ac:cxnSpMkLst>
+            <pc:docMk/>
+            <pc:sldMk cId="1621346635" sldId="709"/>
+            <ac:cxnSpMk id="14" creationId="{A9CC7847-F374-2F79-8CDC-B7DC889CAF6E}"/>
+          </ac:cxnSpMkLst>
+        </pc:cxnChg>
+        <pc:cxnChg chg="add mod">
+          <ac:chgData name="Gerth Stølting Brodal" userId="04ef4784-6591-4f86-a140-f5c3b108582a" providerId="ADAL" clId="{73BAC7D6-516A-44B5-B4B0-C7B08CA8B392}" dt="2026-04-20T12:24:55.107" v="637" actId="1076"/>
+          <ac:cxnSpMkLst>
+            <pc:docMk/>
+            <pc:sldMk cId="1621346635" sldId="709"/>
+            <ac:cxnSpMk id="25" creationId="{4FC47C59-ECA7-41A0-4638-6C89CCCFB524}"/>
+          </ac:cxnSpMkLst>
+        </pc:cxnChg>
+        <pc:cxnChg chg="add mod">
+          <ac:chgData name="Gerth Stølting Brodal" userId="04ef4784-6591-4f86-a140-f5c3b108582a" providerId="ADAL" clId="{73BAC7D6-516A-44B5-B4B0-C7B08CA8B392}" dt="2026-04-20T12:24:43.779" v="636" actId="1076"/>
+          <ac:cxnSpMkLst>
+            <pc:docMk/>
+            <pc:sldMk cId="1621346635" sldId="709"/>
+            <ac:cxnSpMk id="28" creationId="{C054B758-A5E4-6A51-D197-320D28CE5435}"/>
+          </ac:cxnSpMkLst>
+        </pc:cxnChg>
       </pc:sldChg>
     </pc:docChg>
   </pc:docChgLst>
@@ -260,7 +438,7 @@
           <a:p>
             <a:fld id="{FB1A172F-81D4-4DC4-9113-1DBD56EC3646}" type="datetimeFigureOut">
               <a:rPr lang="en-US" smtClean="0"/>
-              <a:t>2026-01-24</a:t>
+              <a:t>4/20/2026</a:t>
             </a:fld>
             <a:endParaRPr lang="en-US"/>
           </a:p>
@@ -695,6 +873,93 @@
 </p:notes>
 </file>
 
+<file path=ppt/notesSlides/notesSlide3.xml><?xml version="1.0" encoding="utf-8"?>
+<p:notes xmlns:a="http://schemas.openxmlformats.org/drawingml/2006/main" xmlns:r="http://schemas.openxmlformats.org/officeDocument/2006/relationships" xmlns:p="http://schemas.openxmlformats.org/presentationml/2006/main">
+  <p:cSld>
+    <p:spTree>
+      <p:nvGrpSpPr>
+        <p:cNvPr id="1" name=""/>
+        <p:cNvGrpSpPr/>
+        <p:nvPr/>
+      </p:nvGrpSpPr>
+      <p:grpSpPr>
+        <a:xfrm>
+          <a:off x="0" y="0"/>
+          <a:ext cx="0" cy="0"/>
+          <a:chOff x="0" y="0"/>
+          <a:chExt cx="0" cy="0"/>
+        </a:xfrm>
+      </p:grpSpPr>
+      <p:sp>
+        <p:nvSpPr>
+          <p:cNvPr id="2" name="Slide Image Placeholder 1"/>
+          <p:cNvSpPr>
+            <a:spLocks noGrp="1" noRot="1" noChangeAspect="1"/>
+          </p:cNvSpPr>
+          <p:nvPr>
+            <p:ph type="sldImg"/>
+          </p:nvPr>
+        </p:nvSpPr>
+        <p:spPr/>
+      </p:sp>
+      <p:sp>
+        <p:nvSpPr>
+          <p:cNvPr id="3" name="Notes Placeholder 2"/>
+          <p:cNvSpPr>
+            <a:spLocks noGrp="1"/>
+          </p:cNvSpPr>
+          <p:nvPr>
+            <p:ph type="body" idx="1"/>
+          </p:nvPr>
+        </p:nvSpPr>
+        <p:spPr/>
+        <p:txBody>
+          <a:bodyPr/>
+          <a:lstStyle/>
+          <a:p>
+            <a:r>
+              <a:rPr lang="en-US" b="1" dirty="0"/>
+              <a:t>Crucial - disable AI assistants</a:t>
+            </a:r>
+          </a:p>
+        </p:txBody>
+      </p:sp>
+      <p:sp>
+        <p:nvSpPr>
+          <p:cNvPr id="4" name="Slide Number Placeholder 3"/>
+          <p:cNvSpPr>
+            <a:spLocks noGrp="1"/>
+          </p:cNvSpPr>
+          <p:nvPr>
+            <p:ph type="sldNum" sz="quarter" idx="5"/>
+          </p:nvPr>
+        </p:nvSpPr>
+        <p:spPr/>
+        <p:txBody>
+          <a:bodyPr/>
+          <a:lstStyle/>
+          <a:p>
+            <a:fld id="{CD563DD8-32AB-41BE-B1C6-8EAC45222ACE}" type="slidenum">
+              <a:rPr lang="en-US" smtClean="0"/>
+              <a:t>4</a:t>
+            </a:fld>
+            <a:endParaRPr lang="en-US"/>
+          </a:p>
+        </p:txBody>
+      </p:sp>
+    </p:spTree>
+    <p:extLst>
+      <p:ext uri="{BB962C8B-B14F-4D97-AF65-F5344CB8AC3E}">
+        <p14:creationId xmlns:p14="http://schemas.microsoft.com/office/powerpoint/2010/main" val="4003924965"/>
+      </p:ext>
+    </p:extLst>
+  </p:cSld>
+  <p:clrMapOvr>
+    <a:masterClrMapping/>
+  </p:clrMapOvr>
+</p:notes>
+</file>
+
 <file path=ppt/slideLayouts/slideLayout1.xml><?xml version="1.0" encoding="utf-8"?>
 <p:sldLayout xmlns:a="http://schemas.openxmlformats.org/drawingml/2006/main" xmlns:r="http://schemas.openxmlformats.org/officeDocument/2006/relationships" xmlns:p="http://schemas.openxmlformats.org/presentationml/2006/main" type="title" preserve="1">
   <p:cSld name="Title Slide">
@@ -832,7 +1097,7 @@
           <a:p>
             <a:fld id="{0560A9CD-0304-4E0B-9E82-E7E0115DE05B}" type="datetimeFigureOut">
               <a:rPr lang="en-US" smtClean="0"/>
-              <a:t>2026-01-24</a:t>
+              <a:t>4/20/2026</a:t>
             </a:fld>
             <a:endParaRPr lang="en-US"/>
           </a:p>
@@ -1000,7 +1265,7 @@
           <a:p>
             <a:fld id="{0560A9CD-0304-4E0B-9E82-E7E0115DE05B}" type="datetimeFigureOut">
               <a:rPr lang="en-US" smtClean="0"/>
-              <a:t>2026-01-24</a:t>
+              <a:t>4/20/2026</a:t>
             </a:fld>
             <a:endParaRPr lang="en-US"/>
           </a:p>
@@ -1178,7 +1443,7 @@
           <a:p>
             <a:fld id="{0560A9CD-0304-4E0B-9E82-E7E0115DE05B}" type="datetimeFigureOut">
               <a:rPr lang="en-US" smtClean="0"/>
-              <a:t>2026-01-24</a:t>
+              <a:t>4/20/2026</a:t>
             </a:fld>
             <a:endParaRPr lang="en-US"/>
           </a:p>
@@ -1361,7 +1626,7 @@
           <a:p>
             <a:fld id="{0560A9CD-0304-4E0B-9E82-E7E0115DE05B}" type="datetimeFigureOut">
               <a:rPr lang="en-US" smtClean="0"/>
-              <a:t>2026-01-24</a:t>
+              <a:t>4/20/2026</a:t>
             </a:fld>
             <a:endParaRPr lang="en-US"/>
           </a:p>
@@ -1606,7 +1871,7 @@
           <a:p>
             <a:fld id="{0560A9CD-0304-4E0B-9E82-E7E0115DE05B}" type="datetimeFigureOut">
               <a:rPr lang="en-US" smtClean="0"/>
-              <a:t>2026-01-24</a:t>
+              <a:t>4/20/2026</a:t>
             </a:fld>
             <a:endParaRPr lang="en-US"/>
           </a:p>
@@ -1835,7 +2100,7 @@
           <a:p>
             <a:fld id="{0560A9CD-0304-4E0B-9E82-E7E0115DE05B}" type="datetimeFigureOut">
               <a:rPr lang="en-US" smtClean="0"/>
-              <a:t>2026-01-24</a:t>
+              <a:t>4/20/2026</a:t>
             </a:fld>
             <a:endParaRPr lang="en-US"/>
           </a:p>
@@ -2199,7 +2464,7 @@
           <a:p>
             <a:fld id="{0560A9CD-0304-4E0B-9E82-E7E0115DE05B}" type="datetimeFigureOut">
               <a:rPr lang="en-US" smtClean="0"/>
-              <a:t>2026-01-24</a:t>
+              <a:t>4/20/2026</a:t>
             </a:fld>
             <a:endParaRPr lang="en-US"/>
           </a:p>
@@ -2316,7 +2581,7 @@
           <a:p>
             <a:fld id="{0560A9CD-0304-4E0B-9E82-E7E0115DE05B}" type="datetimeFigureOut">
               <a:rPr lang="en-US" smtClean="0"/>
-              <a:t>2026-01-24</a:t>
+              <a:t>4/20/2026</a:t>
             </a:fld>
             <a:endParaRPr lang="en-US"/>
           </a:p>
@@ -2411,7 +2676,7 @@
           <a:p>
             <a:fld id="{0560A9CD-0304-4E0B-9E82-E7E0115DE05B}" type="datetimeFigureOut">
               <a:rPr lang="en-US" smtClean="0"/>
-              <a:t>2026-01-24</a:t>
+              <a:t>4/20/2026</a:t>
             </a:fld>
             <a:endParaRPr lang="en-US"/>
           </a:p>
@@ -2686,7 +2951,7 @@
           <a:p>
             <a:fld id="{0560A9CD-0304-4E0B-9E82-E7E0115DE05B}" type="datetimeFigureOut">
               <a:rPr lang="en-US" smtClean="0"/>
-              <a:t>2026-01-24</a:t>
+              <a:t>4/20/2026</a:t>
             </a:fld>
             <a:endParaRPr lang="en-US"/>
           </a:p>
@@ -2938,7 +3203,7 @@
           <a:p>
             <a:fld id="{0560A9CD-0304-4E0B-9E82-E7E0115DE05B}" type="datetimeFigureOut">
               <a:rPr lang="en-US" smtClean="0"/>
-              <a:t>2026-01-24</a:t>
+              <a:t>4/20/2026</a:t>
             </a:fld>
             <a:endParaRPr lang="en-US"/>
           </a:p>
@@ -3149,7 +3414,7 @@
           <a:p>
             <a:fld id="{0560A9CD-0304-4E0B-9E82-E7E0115DE05B}" type="datetimeFigureOut">
               <a:rPr lang="en-US" smtClean="0"/>
-              <a:t>2026-01-24</a:t>
+              <a:t>4/20/2026</a:t>
             </a:fld>
             <a:endParaRPr lang="en-US"/>
           </a:p>
@@ -3855,7 +4120,7 @@
             </a:r>
             <a:r>
               <a:rPr lang="da-DK" dirty="0"/>
-              <a:t> + upload .zip</a:t>
+              <a:t> + upload new .zip</a:t>
             </a:r>
           </a:p>
           <a:p>
@@ -5979,6 +6244,805 @@
           <a:chExt cx="0" cy="0"/>
         </a:xfrm>
       </p:grpSpPr>
+      <p:pic>
+        <p:nvPicPr>
+          <p:cNvPr id="42" name="Picture 41">
+            <a:extLst>
+              <a:ext uri="{FF2B5EF4-FFF2-40B4-BE49-F238E27FC236}">
+                <a16:creationId xmlns:a16="http://schemas.microsoft.com/office/drawing/2014/main" id="{422E1ED9-C2CA-2180-0933-AE9C3478D57A}"/>
+              </a:ext>
+            </a:extLst>
+          </p:cNvPr>
+          <p:cNvPicPr>
+            <a:picLocks noChangeAspect="1"/>
+          </p:cNvPicPr>
+          <p:nvPr/>
+        </p:nvPicPr>
+        <p:blipFill>
+          <a:blip r:embed="rId3"/>
+          <a:stretch>
+            <a:fillRect/>
+          </a:stretch>
+        </p:blipFill>
+        <p:spPr>
+          <a:xfrm>
+            <a:off x="1660673" y="898367"/>
+            <a:ext cx="10424290" cy="5863663"/>
+          </a:xfrm>
+          <a:prstGeom prst="rect">
+            <a:avLst/>
+          </a:prstGeom>
+          <a:ln>
+            <a:solidFill>
+              <a:schemeClr val="tx1"/>
+            </a:solidFill>
+          </a:ln>
+        </p:spPr>
+      </p:pic>
+      <p:sp>
+        <p:nvSpPr>
+          <p:cNvPr id="2" name="Title 1">
+            <a:extLst>
+              <a:ext uri="{FF2B5EF4-FFF2-40B4-BE49-F238E27FC236}">
+                <a16:creationId xmlns:a16="http://schemas.microsoft.com/office/drawing/2014/main" id="{A4839964-8178-89B3-04C4-FDBFEA7CD89E}"/>
+              </a:ext>
+            </a:extLst>
+          </p:cNvPr>
+          <p:cNvSpPr>
+            <a:spLocks noGrp="1"/>
+          </p:cNvSpPr>
+          <p:nvPr>
+            <p:ph type="title"/>
+          </p:nvPr>
+        </p:nvSpPr>
+        <p:spPr>
+          <a:xfrm>
+            <a:off x="143431" y="32831"/>
+            <a:ext cx="3268509" cy="923331"/>
+          </a:xfrm>
+        </p:spPr>
+        <p:txBody>
+          <a:bodyPr>
+            <a:normAutofit fontScale="90000"/>
+          </a:bodyPr>
+          <a:lstStyle/>
+          <a:p>
+            <a:r>
+              <a:rPr lang="en-US" dirty="0"/>
+              <a:t>Using VS Code</a:t>
+            </a:r>
+          </a:p>
+        </p:txBody>
+      </p:sp>
+      <p:cxnSp>
+        <p:nvCxnSpPr>
+          <p:cNvPr id="6" name="Straight Arrow Connector 5">
+            <a:extLst>
+              <a:ext uri="{FF2B5EF4-FFF2-40B4-BE49-F238E27FC236}">
+                <a16:creationId xmlns:a16="http://schemas.microsoft.com/office/drawing/2014/main" id="{A250C8EE-B57E-773A-A776-D344E124516D}"/>
+              </a:ext>
+            </a:extLst>
+          </p:cNvPr>
+          <p:cNvCxnSpPr>
+            <a:cxnSpLocks/>
+          </p:cNvCxnSpPr>
+          <p:nvPr/>
+        </p:nvCxnSpPr>
+        <p:spPr>
+          <a:xfrm flipH="1">
+            <a:off x="10384679" y="3159725"/>
+            <a:ext cx="501012" cy="563832"/>
+          </a:xfrm>
+          <a:prstGeom prst="straightConnector1">
+            <a:avLst/>
+          </a:prstGeom>
+          <a:ln w="76200">
+            <a:solidFill>
+              <a:srgbClr val="C00000"/>
+            </a:solidFill>
+            <a:tailEnd type="triangle"/>
+          </a:ln>
+        </p:spPr>
+        <p:style>
+          <a:lnRef idx="1">
+            <a:schemeClr val="accent1"/>
+          </a:lnRef>
+          <a:fillRef idx="0">
+            <a:schemeClr val="accent1"/>
+          </a:fillRef>
+          <a:effectRef idx="0">
+            <a:schemeClr val="accent1"/>
+          </a:effectRef>
+          <a:fontRef idx="minor">
+            <a:schemeClr val="tx1"/>
+          </a:fontRef>
+        </p:style>
+      </p:cxnSp>
+      <p:cxnSp>
+        <p:nvCxnSpPr>
+          <p:cNvPr id="9" name="Straight Arrow Connector 8">
+            <a:extLst>
+              <a:ext uri="{FF2B5EF4-FFF2-40B4-BE49-F238E27FC236}">
+                <a16:creationId xmlns:a16="http://schemas.microsoft.com/office/drawing/2014/main" id="{A8117F7D-C276-8AE8-3E95-77E9E6528BC5}"/>
+              </a:ext>
+            </a:extLst>
+          </p:cNvPr>
+          <p:cNvCxnSpPr>
+            <a:cxnSpLocks/>
+          </p:cNvCxnSpPr>
+          <p:nvPr/>
+        </p:nvCxnSpPr>
+        <p:spPr>
+          <a:xfrm flipH="1">
+            <a:off x="3778054" y="500528"/>
+            <a:ext cx="236263" cy="550494"/>
+          </a:xfrm>
+          <a:prstGeom prst="straightConnector1">
+            <a:avLst/>
+          </a:prstGeom>
+          <a:ln w="76200">
+            <a:solidFill>
+              <a:srgbClr val="C00000"/>
+            </a:solidFill>
+            <a:tailEnd type="triangle"/>
+          </a:ln>
+        </p:spPr>
+        <p:style>
+          <a:lnRef idx="1">
+            <a:schemeClr val="accent1"/>
+          </a:lnRef>
+          <a:fillRef idx="0">
+            <a:schemeClr val="accent1"/>
+          </a:fillRef>
+          <a:effectRef idx="0">
+            <a:schemeClr val="accent1"/>
+          </a:effectRef>
+          <a:fontRef idx="minor">
+            <a:schemeClr val="tx1"/>
+          </a:fontRef>
+        </p:style>
+      </p:cxnSp>
+      <p:sp>
+        <p:nvSpPr>
+          <p:cNvPr id="10" name="TextBox 9">
+            <a:extLst>
+              <a:ext uri="{FF2B5EF4-FFF2-40B4-BE49-F238E27FC236}">
+                <a16:creationId xmlns:a16="http://schemas.microsoft.com/office/drawing/2014/main" id="{0A1E62CB-F7E9-1988-4B21-7A499DC0F6A3}"/>
+              </a:ext>
+            </a:extLst>
+          </p:cNvPr>
+          <p:cNvSpPr txBox="1"/>
+          <p:nvPr/>
+        </p:nvSpPr>
+        <p:spPr>
+          <a:xfrm>
+            <a:off x="9785446" y="1857171"/>
+            <a:ext cx="2121662" cy="1277273"/>
+          </a:xfrm>
+          <a:prstGeom prst="rect">
+            <a:avLst/>
+          </a:prstGeom>
+          <a:noFill/>
+        </p:spPr>
+        <p:txBody>
+          <a:bodyPr wrap="square" rtlCol="0">
+            <a:spAutoFit/>
+          </a:bodyPr>
+          <a:lstStyle/>
+          <a:p>
+            <a:pPr algn="ctr"/>
+            <a:r>
+              <a:rPr lang="en-US" dirty="0">
+                <a:solidFill>
+                  <a:srgbClr val="C00000"/>
+                </a:solidFill>
+              </a:rPr>
+              <a:t>Ctrl-j</a:t>
+            </a:r>
+          </a:p>
+          <a:p>
+            <a:pPr algn="ctr"/>
+            <a:r>
+              <a:rPr lang="en-US" dirty="0">
+                <a:solidFill>
+                  <a:srgbClr val="C00000"/>
+                </a:solidFill>
+              </a:rPr>
+              <a:t>Toggles terminal</a:t>
+            </a:r>
+          </a:p>
+          <a:p>
+            <a:pPr algn="ctr">
+              <a:spcBef>
+                <a:spcPts val="600"/>
+              </a:spcBef>
+            </a:pPr>
+            <a:r>
+              <a:rPr lang="en-US" dirty="0">
+                <a:solidFill>
+                  <a:srgbClr val="C00000"/>
+                </a:solidFill>
+              </a:rPr>
+              <a:t>Ctrl-l</a:t>
+            </a:r>
+          </a:p>
+          <a:p>
+            <a:pPr algn="ctr"/>
+            <a:r>
+              <a:rPr lang="en-US" dirty="0">
+                <a:solidFill>
+                  <a:srgbClr val="C00000"/>
+                </a:solidFill>
+              </a:rPr>
+              <a:t>Clears terminal</a:t>
+            </a:r>
+          </a:p>
+        </p:txBody>
+      </p:sp>
+      <p:cxnSp>
+        <p:nvCxnSpPr>
+          <p:cNvPr id="12" name="Straight Arrow Connector 11">
+            <a:extLst>
+              <a:ext uri="{FF2B5EF4-FFF2-40B4-BE49-F238E27FC236}">
+                <a16:creationId xmlns:a16="http://schemas.microsoft.com/office/drawing/2014/main" id="{615B64E8-C9CB-2016-0FC3-88D66041AEC5}"/>
+              </a:ext>
+            </a:extLst>
+          </p:cNvPr>
+          <p:cNvCxnSpPr>
+            <a:cxnSpLocks/>
+          </p:cNvCxnSpPr>
+          <p:nvPr/>
+        </p:nvCxnSpPr>
+        <p:spPr>
+          <a:xfrm flipV="1">
+            <a:off x="7657360" y="4144314"/>
+            <a:ext cx="344015" cy="604640"/>
+          </a:xfrm>
+          <a:prstGeom prst="straightConnector1">
+            <a:avLst/>
+          </a:prstGeom>
+          <a:ln w="76200">
+            <a:solidFill>
+              <a:srgbClr val="C00000"/>
+            </a:solidFill>
+            <a:tailEnd type="triangle"/>
+          </a:ln>
+        </p:spPr>
+        <p:style>
+          <a:lnRef idx="1">
+            <a:schemeClr val="accent1"/>
+          </a:lnRef>
+          <a:fillRef idx="0">
+            <a:schemeClr val="accent1"/>
+          </a:fillRef>
+          <a:effectRef idx="0">
+            <a:schemeClr val="accent1"/>
+          </a:effectRef>
+          <a:fontRef idx="minor">
+            <a:schemeClr val="tx1"/>
+          </a:fontRef>
+        </p:style>
+      </p:cxnSp>
+      <p:cxnSp>
+        <p:nvCxnSpPr>
+          <p:cNvPr id="14" name="Straight Arrow Connector 13">
+            <a:extLst>
+              <a:ext uri="{FF2B5EF4-FFF2-40B4-BE49-F238E27FC236}">
+                <a16:creationId xmlns:a16="http://schemas.microsoft.com/office/drawing/2014/main" id="{A9CC7847-F374-2F79-8CDC-B7DC889CAF6E}"/>
+              </a:ext>
+            </a:extLst>
+          </p:cNvPr>
+          <p:cNvCxnSpPr>
+            <a:cxnSpLocks/>
+          </p:cNvCxnSpPr>
+          <p:nvPr/>
+        </p:nvCxnSpPr>
+        <p:spPr>
+          <a:xfrm>
+            <a:off x="8692648" y="643233"/>
+            <a:ext cx="542879" cy="593519"/>
+          </a:xfrm>
+          <a:prstGeom prst="straightConnector1">
+            <a:avLst/>
+          </a:prstGeom>
+          <a:ln w="76200">
+            <a:solidFill>
+              <a:srgbClr val="C00000"/>
+            </a:solidFill>
+            <a:tailEnd type="triangle"/>
+          </a:ln>
+        </p:spPr>
+        <p:style>
+          <a:lnRef idx="1">
+            <a:schemeClr val="accent1"/>
+          </a:lnRef>
+          <a:fillRef idx="0">
+            <a:schemeClr val="accent1"/>
+          </a:fillRef>
+          <a:effectRef idx="0">
+            <a:schemeClr val="accent1"/>
+          </a:effectRef>
+          <a:fontRef idx="minor">
+            <a:schemeClr val="tx1"/>
+          </a:fontRef>
+        </p:style>
+      </p:cxnSp>
+      <p:sp>
+        <p:nvSpPr>
+          <p:cNvPr id="15" name="TextBox 14">
+            <a:extLst>
+              <a:ext uri="{FF2B5EF4-FFF2-40B4-BE49-F238E27FC236}">
+                <a16:creationId xmlns:a16="http://schemas.microsoft.com/office/drawing/2014/main" id="{79F44FD5-BCE3-076F-9F02-5A3789E615F4}"/>
+              </a:ext>
+            </a:extLst>
+          </p:cNvPr>
+          <p:cNvSpPr txBox="1"/>
+          <p:nvPr/>
+        </p:nvSpPr>
+        <p:spPr>
+          <a:xfrm>
+            <a:off x="7657360" y="0"/>
+            <a:ext cx="4090023" cy="923330"/>
+          </a:xfrm>
+          <a:prstGeom prst="rect">
+            <a:avLst/>
+          </a:prstGeom>
+          <a:noFill/>
+        </p:spPr>
+        <p:txBody>
+          <a:bodyPr wrap="square" rtlCol="0">
+            <a:spAutoFit/>
+          </a:bodyPr>
+          <a:lstStyle/>
+          <a:p>
+            <a:r>
+              <a:rPr lang="en-US" dirty="0">
+                <a:solidFill>
+                  <a:srgbClr val="C00000"/>
+                </a:solidFill>
+              </a:rPr>
+              <a:t>Place terminal right</a:t>
+            </a:r>
+          </a:p>
+          <a:p>
+            <a:r>
+              <a:rPr lang="en-US" i="1" dirty="0">
+                <a:solidFill>
+                  <a:srgbClr val="C00000"/>
+                </a:solidFill>
+              </a:rPr>
+              <a:t>Right click menu </a:t>
+            </a:r>
+            <a:r>
+              <a:rPr lang="en-US" dirty="0">
+                <a:solidFill>
+                  <a:srgbClr val="C00000"/>
+                </a:solidFill>
+              </a:rPr>
+              <a:t>&gt; </a:t>
+            </a:r>
+            <a:r>
+              <a:rPr lang="en-US" i="1" dirty="0">
+                <a:solidFill>
+                  <a:srgbClr val="C00000"/>
+                </a:solidFill>
+              </a:rPr>
+              <a:t>Panel position </a:t>
+            </a:r>
+            <a:r>
+              <a:rPr lang="en-US" dirty="0">
+                <a:solidFill>
+                  <a:srgbClr val="C00000"/>
+                </a:solidFill>
+              </a:rPr>
+              <a:t>&gt; </a:t>
+            </a:r>
+            <a:r>
+              <a:rPr lang="en-US" i="1" dirty="0">
+                <a:solidFill>
+                  <a:srgbClr val="C00000"/>
+                </a:solidFill>
+              </a:rPr>
+              <a:t>Right</a:t>
+            </a:r>
+          </a:p>
+          <a:p>
+            <a:endParaRPr lang="en-US" dirty="0">
+              <a:solidFill>
+                <a:srgbClr val="C00000"/>
+              </a:solidFill>
+            </a:endParaRPr>
+          </a:p>
+        </p:txBody>
+      </p:sp>
+      <p:sp>
+        <p:nvSpPr>
+          <p:cNvPr id="16" name="TextBox 15">
+            <a:extLst>
+              <a:ext uri="{FF2B5EF4-FFF2-40B4-BE49-F238E27FC236}">
+                <a16:creationId xmlns:a16="http://schemas.microsoft.com/office/drawing/2014/main" id="{C078C52F-5AE4-B055-8261-D7352360BB9A}"/>
+              </a:ext>
+            </a:extLst>
+          </p:cNvPr>
+          <p:cNvSpPr txBox="1"/>
+          <p:nvPr/>
+        </p:nvSpPr>
+        <p:spPr>
+          <a:xfrm>
+            <a:off x="4004666" y="148020"/>
+            <a:ext cx="2952168" cy="369332"/>
+          </a:xfrm>
+          <a:prstGeom prst="rect">
+            <a:avLst/>
+          </a:prstGeom>
+          <a:noFill/>
+        </p:spPr>
+        <p:txBody>
+          <a:bodyPr wrap="square" rtlCol="0">
+            <a:spAutoFit/>
+          </a:bodyPr>
+          <a:lstStyle/>
+          <a:p>
+            <a:r>
+              <a:rPr lang="en-US" dirty="0">
+                <a:solidFill>
+                  <a:srgbClr val="C00000"/>
+                </a:solidFill>
+              </a:rPr>
+              <a:t>F11 toggles full screen</a:t>
+            </a:r>
+          </a:p>
+        </p:txBody>
+      </p:sp>
+      <p:sp>
+        <p:nvSpPr>
+          <p:cNvPr id="19" name="TextBox 18">
+            <a:extLst>
+              <a:ext uri="{FF2B5EF4-FFF2-40B4-BE49-F238E27FC236}">
+                <a16:creationId xmlns:a16="http://schemas.microsoft.com/office/drawing/2014/main" id="{EBCC6460-8B81-C7D8-944F-4BA9F694AD3A}"/>
+              </a:ext>
+            </a:extLst>
+          </p:cNvPr>
+          <p:cNvSpPr txBox="1"/>
+          <p:nvPr/>
+        </p:nvSpPr>
+        <p:spPr>
+          <a:xfrm>
+            <a:off x="5421459" y="4650122"/>
+            <a:ext cx="3070750" cy="646331"/>
+          </a:xfrm>
+          <a:prstGeom prst="rect">
+            <a:avLst/>
+          </a:prstGeom>
+          <a:noFill/>
+        </p:spPr>
+        <p:txBody>
+          <a:bodyPr wrap="square" rtlCol="0">
+            <a:spAutoFit/>
+          </a:bodyPr>
+          <a:lstStyle/>
+          <a:p>
+            <a:pPr algn="ctr"/>
+            <a:r>
+              <a:rPr lang="en-US" dirty="0">
+                <a:solidFill>
+                  <a:srgbClr val="C00000"/>
+                </a:solidFill>
+              </a:rPr>
+              <a:t>Split tab </a:t>
+            </a:r>
+            <a:br>
+              <a:rPr lang="en-US" dirty="0">
+                <a:solidFill>
+                  <a:srgbClr val="C00000"/>
+                </a:solidFill>
+              </a:rPr>
+            </a:br>
+            <a:r>
+              <a:rPr lang="en-US" dirty="0">
+                <a:solidFill>
+                  <a:srgbClr val="C00000"/>
+                </a:solidFill>
+              </a:rPr>
+              <a:t>hold “alt” to split horizontally</a:t>
+            </a:r>
+          </a:p>
+        </p:txBody>
+      </p:sp>
+      <p:cxnSp>
+        <p:nvCxnSpPr>
+          <p:cNvPr id="25" name="Straight Arrow Connector 24">
+            <a:extLst>
+              <a:ext uri="{FF2B5EF4-FFF2-40B4-BE49-F238E27FC236}">
+                <a16:creationId xmlns:a16="http://schemas.microsoft.com/office/drawing/2014/main" id="{4FC47C59-ECA7-41A0-4638-6C89CCCFB524}"/>
+              </a:ext>
+            </a:extLst>
+          </p:cNvPr>
+          <p:cNvCxnSpPr>
+            <a:cxnSpLocks/>
+          </p:cNvCxnSpPr>
+          <p:nvPr/>
+        </p:nvCxnSpPr>
+        <p:spPr>
+          <a:xfrm flipV="1">
+            <a:off x="1007034" y="1391156"/>
+            <a:ext cx="693269" cy="206386"/>
+          </a:xfrm>
+          <a:prstGeom prst="straightConnector1">
+            <a:avLst/>
+          </a:prstGeom>
+          <a:ln w="76200">
+            <a:solidFill>
+              <a:srgbClr val="C00000"/>
+            </a:solidFill>
+            <a:tailEnd type="triangle"/>
+          </a:ln>
+        </p:spPr>
+        <p:style>
+          <a:lnRef idx="1">
+            <a:schemeClr val="accent1"/>
+          </a:lnRef>
+          <a:fillRef idx="0">
+            <a:schemeClr val="accent1"/>
+          </a:fillRef>
+          <a:effectRef idx="0">
+            <a:schemeClr val="accent1"/>
+          </a:effectRef>
+          <a:fontRef idx="minor">
+            <a:schemeClr val="tx1"/>
+          </a:fontRef>
+        </p:style>
+      </p:cxnSp>
+      <p:sp>
+        <p:nvSpPr>
+          <p:cNvPr id="27" name="TextBox 26">
+            <a:extLst>
+              <a:ext uri="{FF2B5EF4-FFF2-40B4-BE49-F238E27FC236}">
+                <a16:creationId xmlns:a16="http://schemas.microsoft.com/office/drawing/2014/main" id="{F72ECF3C-3D78-F5CE-F77B-9377DE39CDB8}"/>
+              </a:ext>
+            </a:extLst>
+          </p:cNvPr>
+          <p:cNvSpPr txBox="1"/>
+          <p:nvPr/>
+        </p:nvSpPr>
+        <p:spPr>
+          <a:xfrm>
+            <a:off x="41687" y="1580172"/>
+            <a:ext cx="1311981" cy="1554272"/>
+          </a:xfrm>
+          <a:prstGeom prst="rect">
+            <a:avLst/>
+          </a:prstGeom>
+          <a:noFill/>
+        </p:spPr>
+        <p:txBody>
+          <a:bodyPr wrap="square" rtlCol="0">
+            <a:spAutoFit/>
+          </a:bodyPr>
+          <a:lstStyle/>
+          <a:p>
+            <a:pPr algn="ctr"/>
+            <a:r>
+              <a:rPr lang="en-US" dirty="0">
+                <a:solidFill>
+                  <a:srgbClr val="C00000"/>
+                </a:solidFill>
+              </a:rPr>
+              <a:t>ctrl-k ctrl-o</a:t>
+            </a:r>
+            <a:br>
+              <a:rPr lang="en-US" dirty="0">
+                <a:solidFill>
+                  <a:srgbClr val="C00000"/>
+                </a:solidFill>
+              </a:rPr>
+            </a:br>
+            <a:r>
+              <a:rPr lang="en-US" dirty="0">
+                <a:solidFill>
+                  <a:srgbClr val="C00000"/>
+                </a:solidFill>
+              </a:rPr>
+              <a:t>Open folder</a:t>
+            </a:r>
+          </a:p>
+          <a:p>
+            <a:pPr algn="ctr">
+              <a:spcBef>
+                <a:spcPts val="600"/>
+              </a:spcBef>
+            </a:pPr>
+            <a:r>
+              <a:rPr lang="en-US" dirty="0">
+                <a:solidFill>
+                  <a:srgbClr val="C00000"/>
+                </a:solidFill>
+              </a:rPr>
+              <a:t>Click to toggle file explorer</a:t>
+            </a:r>
+          </a:p>
+        </p:txBody>
+      </p:sp>
+      <p:cxnSp>
+        <p:nvCxnSpPr>
+          <p:cNvPr id="28" name="Straight Arrow Connector 27">
+            <a:extLst>
+              <a:ext uri="{FF2B5EF4-FFF2-40B4-BE49-F238E27FC236}">
+                <a16:creationId xmlns:a16="http://schemas.microsoft.com/office/drawing/2014/main" id="{C054B758-A5E4-6A51-D197-320D28CE5435}"/>
+              </a:ext>
+            </a:extLst>
+          </p:cNvPr>
+          <p:cNvCxnSpPr>
+            <a:cxnSpLocks/>
+          </p:cNvCxnSpPr>
+          <p:nvPr/>
+        </p:nvCxnSpPr>
+        <p:spPr>
+          <a:xfrm flipV="1">
+            <a:off x="849136" y="2805127"/>
+            <a:ext cx="851167" cy="1112466"/>
+          </a:xfrm>
+          <a:prstGeom prst="straightConnector1">
+            <a:avLst/>
+          </a:prstGeom>
+          <a:ln w="76200">
+            <a:solidFill>
+              <a:srgbClr val="C00000"/>
+            </a:solidFill>
+            <a:tailEnd type="triangle"/>
+          </a:ln>
+        </p:spPr>
+        <p:style>
+          <a:lnRef idx="1">
+            <a:schemeClr val="accent1"/>
+          </a:lnRef>
+          <a:fillRef idx="0">
+            <a:schemeClr val="accent1"/>
+          </a:fillRef>
+          <a:effectRef idx="0">
+            <a:schemeClr val="accent1"/>
+          </a:effectRef>
+          <a:fontRef idx="minor">
+            <a:schemeClr val="tx1"/>
+          </a:fontRef>
+        </p:style>
+      </p:cxnSp>
+      <p:sp>
+        <p:nvSpPr>
+          <p:cNvPr id="30" name="TextBox 29">
+            <a:extLst>
+              <a:ext uri="{FF2B5EF4-FFF2-40B4-BE49-F238E27FC236}">
+                <a16:creationId xmlns:a16="http://schemas.microsoft.com/office/drawing/2014/main" id="{2681E6CD-554F-8D3A-ED30-88D9D04981E2}"/>
+              </a:ext>
+            </a:extLst>
+          </p:cNvPr>
+          <p:cNvSpPr txBox="1"/>
+          <p:nvPr/>
+        </p:nvSpPr>
+        <p:spPr>
+          <a:xfrm>
+            <a:off x="-77706" y="3940516"/>
+            <a:ext cx="1799698" cy="923330"/>
+          </a:xfrm>
+          <a:prstGeom prst="rect">
+            <a:avLst/>
+          </a:prstGeom>
+          <a:noFill/>
+        </p:spPr>
+        <p:txBody>
+          <a:bodyPr wrap="square" rtlCol="0">
+            <a:spAutoFit/>
+          </a:bodyPr>
+          <a:lstStyle/>
+          <a:p>
+            <a:pPr algn="ctr"/>
+            <a:r>
+              <a:rPr lang="en-US" b="1" dirty="0">
+                <a:solidFill>
+                  <a:srgbClr val="C00000"/>
+                </a:solidFill>
+              </a:rPr>
+              <a:t>Disable</a:t>
+            </a:r>
+            <a:br>
+              <a:rPr lang="en-US" b="1" dirty="0">
+                <a:solidFill>
+                  <a:srgbClr val="C00000"/>
+                </a:solidFill>
+              </a:rPr>
+            </a:br>
+            <a:r>
+              <a:rPr lang="en-US" b="1" dirty="0">
+                <a:solidFill>
+                  <a:srgbClr val="C00000"/>
+                </a:solidFill>
+              </a:rPr>
+              <a:t>AI assistants </a:t>
+            </a:r>
+            <a:br>
+              <a:rPr lang="en-US" b="1" dirty="0">
+                <a:solidFill>
+                  <a:srgbClr val="C00000"/>
+                </a:solidFill>
+              </a:rPr>
+            </a:br>
+            <a:r>
+              <a:rPr lang="en-US" b="1" dirty="0">
+                <a:solidFill>
+                  <a:srgbClr val="C00000"/>
+                </a:solidFill>
+              </a:rPr>
+              <a:t>(GitHub Copilot)</a:t>
+            </a:r>
+          </a:p>
+        </p:txBody>
+      </p:sp>
+      <p:pic>
+        <p:nvPicPr>
+          <p:cNvPr id="45" name="Picture 44">
+            <a:extLst>
+              <a:ext uri="{FF2B5EF4-FFF2-40B4-BE49-F238E27FC236}">
+                <a16:creationId xmlns:a16="http://schemas.microsoft.com/office/drawing/2014/main" id="{5BE67AD2-6117-A31F-8C68-3E75AC60DEC6}"/>
+              </a:ext>
+            </a:extLst>
+          </p:cNvPr>
+          <p:cNvPicPr>
+            <a:picLocks noChangeAspect="1"/>
+          </p:cNvPicPr>
+          <p:nvPr/>
+        </p:nvPicPr>
+        <p:blipFill>
+          <a:blip r:embed="rId4" cstate="print">
+            <a:extLst>
+              <a:ext uri="{28A0092B-C50C-407E-A947-70E740481C1C}">
+                <a14:useLocalDpi xmlns:a14="http://schemas.microsoft.com/office/drawing/2010/main" val="0"/>
+              </a:ext>
+            </a:extLst>
+          </a:blip>
+          <a:stretch>
+            <a:fillRect/>
+          </a:stretch>
+        </p:blipFill>
+        <p:spPr>
+          <a:xfrm>
+            <a:off x="547651" y="4863846"/>
+            <a:ext cx="487666" cy="405904"/>
+          </a:xfrm>
+          <a:prstGeom prst="rect">
+            <a:avLst/>
+          </a:prstGeom>
+        </p:spPr>
+      </p:pic>
+    </p:spTree>
+    <p:extLst>
+      <p:ext uri="{BB962C8B-B14F-4D97-AF65-F5344CB8AC3E}">
+        <p14:creationId xmlns:p14="http://schemas.microsoft.com/office/powerpoint/2010/main" val="1621346635"/>
+      </p:ext>
+    </p:extLst>
+  </p:cSld>
+  <p:clrMapOvr>
+    <a:masterClrMapping/>
+  </p:clrMapOvr>
+</p:sld>
+</file>
+
+<file path=ppt/slides/slide5.xml><?xml version="1.0" encoding="utf-8"?>
+<p:sld xmlns:a="http://schemas.openxmlformats.org/drawingml/2006/main" xmlns:r="http://schemas.openxmlformats.org/officeDocument/2006/relationships" xmlns:p="http://schemas.openxmlformats.org/presentationml/2006/main">
+  <p:cSld>
+    <p:spTree>
+      <p:nvGrpSpPr>
+        <p:cNvPr id="1" name=""/>
+        <p:cNvGrpSpPr/>
+        <p:nvPr/>
+      </p:nvGrpSpPr>
+      <p:grpSpPr>
+        <a:xfrm>
+          <a:off x="0" y="0"/>
+          <a:ext cx="0" cy="0"/>
+          <a:chOff x="0" y="0"/>
+          <a:chExt cx="0" cy="0"/>
+        </a:xfrm>
+      </p:grpSpPr>
       <p:sp>
         <p:nvSpPr>
           <p:cNvPr id="2" name="Title 1"/>
@@ -6191,7 +7255,7 @@
 </p:sld>
 </file>
 
-<file path=ppt/slides/slide5.xml><?xml version="1.0" encoding="utf-8"?>
+<file path=ppt/slides/slide6.xml><?xml version="1.0" encoding="utf-8"?>
 <p:sld xmlns:a="http://schemas.openxmlformats.org/drawingml/2006/main" xmlns:r="http://schemas.openxmlformats.org/officeDocument/2006/relationships" xmlns:p="http://schemas.openxmlformats.org/presentationml/2006/main">
   <p:cSld>
     <p:spTree>
@@ -6769,4 +7833,10 @@
     </a:ext>
   </a:extLst>
 </a:theme>
+</file>
+
+<file path=docMetadata/LabelInfo.xml><?xml version="1.0" encoding="utf-8"?>
+<clbl:labelList xmlns:clbl="http://schemas.microsoft.com/office/2020/mipLabelMetadata">
+  <clbl:label id="{61fd1d36-fecb-47ca-b7d7-d0df0370a198}" enabled="0" method="" siteId="{61fd1d36-fecb-47ca-b7d7-d0df0370a198}" removed="1"/>
+</clbl:labelList>
 </file>
</xml_diff>

<commit_message>
all-slides-with-answers.pdf all-slides.pdf exam.pdf exam.pptx
</commit_message>
<xml_diff>
--- a/ipsa/slides/exam.pptx
+++ b/ipsa/slides/exam.pptx
@@ -120,31 +120,23 @@
 </p:presentation>
 </file>
 
-<file path=ppt/revisionInfo.xml><?xml version="1.0" encoding="utf-8"?>
-<p1510:revInfo xmlns:a="http://schemas.openxmlformats.org/drawingml/2006/main" xmlns:r="http://schemas.openxmlformats.org/officeDocument/2006/relationships" xmlns:p1510="http://schemas.microsoft.com/office/powerpoint/2015/10/main">
-  <p1510:revLst>
-    <p1510:client id="{5DFB3D16-2569-4EDF-8550-749E41FF543D}" v="339" dt="2026-04-20T12:50:23.058"/>
-  </p1510:revLst>
-</p1510:revInfo>
-</file>
-
 <file path=ppt/changesInfos/changesInfo1.xml><?xml version="1.0" encoding="utf-8"?>
 <pc:chgInfo xmlns:a="http://schemas.openxmlformats.org/drawingml/2006/main" xmlns:r="http://schemas.openxmlformats.org/officeDocument/2006/relationships" xmlns:ac="http://schemas.microsoft.com/office/drawing/2013/main/command" xmlns:pc="http://schemas.microsoft.com/office/powerpoint/2013/main/command">
   <pc:docChgLst>
     <pc:chgData name="Gerth Stølting Brodal" userId="04ef4784-6591-4f86-a140-f5c3b108582a" providerId="ADAL" clId="{73BAC7D6-516A-44B5-B4B0-C7B08CA8B392}"/>
     <pc:docChg chg="undo custSel addSld modSld">
-      <pc:chgData name="Gerth Stølting Brodal" userId="04ef4784-6591-4f86-a140-f5c3b108582a" providerId="ADAL" clId="{73BAC7D6-516A-44B5-B4B0-C7B08CA8B392}" dt="2026-04-20T12:50:33.999" v="765" actId="1076"/>
+      <pc:chgData name="Gerth Stølting Brodal" userId="04ef4784-6591-4f86-a140-f5c3b108582a" providerId="ADAL" clId="{73BAC7D6-516A-44B5-B4B0-C7B08CA8B392}" dt="2026-05-10T21:56:46.820" v="766" actId="207"/>
       <pc:docMkLst>
         <pc:docMk/>
       </pc:docMkLst>
       <pc:sldChg chg="modSp mod">
-        <pc:chgData name="Gerth Stølting Brodal" userId="04ef4784-6591-4f86-a140-f5c3b108582a" providerId="ADAL" clId="{73BAC7D6-516A-44B5-B4B0-C7B08CA8B392}" dt="2026-04-20T11:14:16.301" v="33" actId="20577"/>
+        <pc:chgData name="Gerth Stølting Brodal" userId="04ef4784-6591-4f86-a140-f5c3b108582a" providerId="ADAL" clId="{73BAC7D6-516A-44B5-B4B0-C7B08CA8B392}" dt="2026-05-10T21:56:46.820" v="766" actId="207"/>
         <pc:sldMkLst>
           <pc:docMk/>
           <pc:sldMk cId="1270503327" sldId="703"/>
         </pc:sldMkLst>
         <pc:spChg chg="mod">
-          <ac:chgData name="Gerth Stølting Brodal" userId="04ef4784-6591-4f86-a140-f5c3b108582a" providerId="ADAL" clId="{73BAC7D6-516A-44B5-B4B0-C7B08CA8B392}" dt="2026-04-20T11:14:16.301" v="33" actId="20577"/>
+          <ac:chgData name="Gerth Stølting Brodal" userId="04ef4784-6591-4f86-a140-f5c3b108582a" providerId="ADAL" clId="{73BAC7D6-516A-44B5-B4B0-C7B08CA8B392}" dt="2026-05-10T21:56:46.820" v="766" actId="207"/>
           <ac:spMkLst>
             <pc:docMk/>
             <pc:sldMk cId="1270503327" sldId="703"/>
@@ -166,36 +158,12 @@
             <ac:spMk id="2" creationId="{A4839964-8178-89B3-04C4-FDBFEA7CD89E}"/>
           </ac:spMkLst>
         </pc:spChg>
-        <pc:spChg chg="del mod">
-          <ac:chgData name="Gerth Stølting Brodal" userId="04ef4784-6591-4f86-a140-f5c3b108582a" providerId="ADAL" clId="{73BAC7D6-516A-44B5-B4B0-C7B08CA8B392}" dt="2026-04-20T12:34:51.062" v="729" actId="478"/>
-          <ac:spMkLst>
-            <pc:docMk/>
-            <pc:sldMk cId="1621346635" sldId="709"/>
-            <ac:spMk id="3" creationId="{6E750014-9145-E154-27EF-1D9E2AB19393}"/>
-          </ac:spMkLst>
-        </pc:spChg>
-        <pc:spChg chg="add del mod">
-          <ac:chgData name="Gerth Stølting Brodal" userId="04ef4784-6591-4f86-a140-f5c3b108582a" providerId="ADAL" clId="{73BAC7D6-516A-44B5-B4B0-C7B08CA8B392}" dt="2026-04-20T11:24:30.795" v="232" actId="478"/>
-          <ac:spMkLst>
-            <pc:docMk/>
-            <pc:sldMk cId="1621346635" sldId="709"/>
-            <ac:spMk id="7" creationId="{BA20E5B2-C0B8-B93C-AC0A-0C02482773D5}"/>
-          </ac:spMkLst>
-        </pc:spChg>
         <pc:spChg chg="add mod">
           <ac:chgData name="Gerth Stølting Brodal" userId="04ef4784-6591-4f86-a140-f5c3b108582a" providerId="ADAL" clId="{73BAC7D6-516A-44B5-B4B0-C7B08CA8B392}" dt="2026-04-20T12:43:05.989" v="762" actId="6549"/>
           <ac:spMkLst>
             <pc:docMk/>
             <pc:sldMk cId="1621346635" sldId="709"/>
             <ac:spMk id="10" creationId="{0A1E62CB-F7E9-1988-4B21-7A499DC0F6A3}"/>
-          </ac:spMkLst>
-        </pc:spChg>
-        <pc:spChg chg="add del mod">
-          <ac:chgData name="Gerth Stølting Brodal" userId="04ef4784-6591-4f86-a140-f5c3b108582a" providerId="ADAL" clId="{73BAC7D6-516A-44B5-B4B0-C7B08CA8B392}" dt="2026-04-20T11:24:29.716" v="231" actId="478"/>
-          <ac:spMkLst>
-            <pc:docMk/>
-            <pc:sldMk cId="1621346635" sldId="709"/>
-            <ac:spMk id="13" creationId="{8595C4BB-7CB7-5BE7-03FB-DD89DB98F0FF}"/>
           </ac:spMkLst>
         </pc:spChg>
         <pc:spChg chg="add mod">
@@ -238,54 +206,6 @@
             <ac:spMk id="30" creationId="{2681E6CD-554F-8D3A-ED30-88D9D04981E2}"/>
           </ac:spMkLst>
         </pc:spChg>
-        <pc:spChg chg="add del mod">
-          <ac:chgData name="Gerth Stølting Brodal" userId="04ef4784-6591-4f86-a140-f5c3b108582a" providerId="ADAL" clId="{73BAC7D6-516A-44B5-B4B0-C7B08CA8B392}" dt="2026-04-20T12:34:56.341" v="730" actId="478"/>
-          <ac:spMkLst>
-            <pc:docMk/>
-            <pc:sldMk cId="1621346635" sldId="709"/>
-            <ac:spMk id="44" creationId="{39F6CAA4-1AA2-48F5-BEA7-256E8CFF95ED}"/>
-          </ac:spMkLst>
-        </pc:spChg>
-        <pc:picChg chg="add del mod">
-          <ac:chgData name="Gerth Stølting Brodal" userId="04ef4784-6591-4f86-a140-f5c3b108582a" providerId="ADAL" clId="{73BAC7D6-516A-44B5-B4B0-C7B08CA8B392}" dt="2026-04-20T11:29:23.833" v="340" actId="478"/>
-          <ac:picMkLst>
-            <pc:docMk/>
-            <pc:sldMk cId="1621346635" sldId="709"/>
-            <ac:picMk id="5" creationId="{7F1A4E26-681F-3085-14B6-9D06EFD1E981}"/>
-          </ac:picMkLst>
-        </pc:picChg>
-        <pc:picChg chg="add del mod ord">
-          <ac:chgData name="Gerth Stølting Brodal" userId="04ef4784-6591-4f86-a140-f5c3b108582a" providerId="ADAL" clId="{73BAC7D6-516A-44B5-B4B0-C7B08CA8B392}" dt="2026-04-20T11:29:59.550" v="347" actId="478"/>
-          <ac:picMkLst>
-            <pc:docMk/>
-            <pc:sldMk cId="1621346635" sldId="709"/>
-            <ac:picMk id="22" creationId="{185FF4AB-0754-696F-1FE5-71F9F5CE9F95}"/>
-          </ac:picMkLst>
-        </pc:picChg>
-        <pc:picChg chg="add del mod ord">
-          <ac:chgData name="Gerth Stølting Brodal" userId="04ef4784-6591-4f86-a140-f5c3b108582a" providerId="ADAL" clId="{73BAC7D6-516A-44B5-B4B0-C7B08CA8B392}" dt="2026-04-20T12:15:57.453" v="494" actId="478"/>
-          <ac:picMkLst>
-            <pc:docMk/>
-            <pc:sldMk cId="1621346635" sldId="709"/>
-            <ac:picMk id="24" creationId="{B068A8F1-C63F-3494-C38A-A2DA994029C3}"/>
-          </ac:picMkLst>
-        </pc:picChg>
-        <pc:picChg chg="add del mod ord">
-          <ac:chgData name="Gerth Stølting Brodal" userId="04ef4784-6591-4f86-a140-f5c3b108582a" providerId="ADAL" clId="{73BAC7D6-516A-44B5-B4B0-C7B08CA8B392}" dt="2026-04-20T12:23:43.232" v="560" actId="478"/>
-          <ac:picMkLst>
-            <pc:docMk/>
-            <pc:sldMk cId="1621346635" sldId="709"/>
-            <ac:picMk id="34" creationId="{6427C406-AFCC-A76F-9CCF-E89F5FEBAE20}"/>
-          </ac:picMkLst>
-        </pc:picChg>
-        <pc:picChg chg="add del mod ord">
-          <ac:chgData name="Gerth Stølting Brodal" userId="04ef4784-6591-4f86-a140-f5c3b108582a" providerId="ADAL" clId="{73BAC7D6-516A-44B5-B4B0-C7B08CA8B392}" dt="2026-04-20T12:29:07.389" v="650" actId="478"/>
-          <ac:picMkLst>
-            <pc:docMk/>
-            <pc:sldMk cId="1621346635" sldId="709"/>
-            <ac:picMk id="40" creationId="{C06F56C5-8911-EA7C-928E-08118F8E009B}"/>
-          </ac:picMkLst>
-        </pc:picChg>
         <pc:picChg chg="add mod ord">
           <ac:chgData name="Gerth Stølting Brodal" userId="04ef4784-6591-4f86-a140-f5c3b108582a" providerId="ADAL" clId="{73BAC7D6-516A-44B5-B4B0-C7B08CA8B392}" dt="2026-04-20T12:35:07.409" v="735" actId="1036"/>
           <ac:picMkLst>
@@ -438,7 +358,7 @@
           <a:p>
             <a:fld id="{FB1A172F-81D4-4DC4-9113-1DBD56EC3646}" type="datetimeFigureOut">
               <a:rPr lang="en-US" smtClean="0"/>
-              <a:t>4/20/2026</a:t>
+              <a:t>5/10/2026</a:t>
             </a:fld>
             <a:endParaRPr lang="en-US"/>
           </a:p>
@@ -1097,7 +1017,7 @@
           <a:p>
             <a:fld id="{0560A9CD-0304-4E0B-9E82-E7E0115DE05B}" type="datetimeFigureOut">
               <a:rPr lang="en-US" smtClean="0"/>
-              <a:t>4/20/2026</a:t>
+              <a:t>5/10/2026</a:t>
             </a:fld>
             <a:endParaRPr lang="en-US"/>
           </a:p>
@@ -1265,7 +1185,7 @@
           <a:p>
             <a:fld id="{0560A9CD-0304-4E0B-9E82-E7E0115DE05B}" type="datetimeFigureOut">
               <a:rPr lang="en-US" smtClean="0"/>
-              <a:t>4/20/2026</a:t>
+              <a:t>5/10/2026</a:t>
             </a:fld>
             <a:endParaRPr lang="en-US"/>
           </a:p>
@@ -1443,7 +1363,7 @@
           <a:p>
             <a:fld id="{0560A9CD-0304-4E0B-9E82-E7E0115DE05B}" type="datetimeFigureOut">
               <a:rPr lang="en-US" smtClean="0"/>
-              <a:t>4/20/2026</a:t>
+              <a:t>5/10/2026</a:t>
             </a:fld>
             <a:endParaRPr lang="en-US"/>
           </a:p>
@@ -1626,7 +1546,7 @@
           <a:p>
             <a:fld id="{0560A9CD-0304-4E0B-9E82-E7E0115DE05B}" type="datetimeFigureOut">
               <a:rPr lang="en-US" smtClean="0"/>
-              <a:t>4/20/2026</a:t>
+              <a:t>5/10/2026</a:t>
             </a:fld>
             <a:endParaRPr lang="en-US"/>
           </a:p>
@@ -1871,7 +1791,7 @@
           <a:p>
             <a:fld id="{0560A9CD-0304-4E0B-9E82-E7E0115DE05B}" type="datetimeFigureOut">
               <a:rPr lang="en-US" smtClean="0"/>
-              <a:t>4/20/2026</a:t>
+              <a:t>5/10/2026</a:t>
             </a:fld>
             <a:endParaRPr lang="en-US"/>
           </a:p>
@@ -2100,7 +2020,7 @@
           <a:p>
             <a:fld id="{0560A9CD-0304-4E0B-9E82-E7E0115DE05B}" type="datetimeFigureOut">
               <a:rPr lang="en-US" smtClean="0"/>
-              <a:t>4/20/2026</a:t>
+              <a:t>5/10/2026</a:t>
             </a:fld>
             <a:endParaRPr lang="en-US"/>
           </a:p>
@@ -2464,7 +2384,7 @@
           <a:p>
             <a:fld id="{0560A9CD-0304-4E0B-9E82-E7E0115DE05B}" type="datetimeFigureOut">
               <a:rPr lang="en-US" smtClean="0"/>
-              <a:t>4/20/2026</a:t>
+              <a:t>5/10/2026</a:t>
             </a:fld>
             <a:endParaRPr lang="en-US"/>
           </a:p>
@@ -2581,7 +2501,7 @@
           <a:p>
             <a:fld id="{0560A9CD-0304-4E0B-9E82-E7E0115DE05B}" type="datetimeFigureOut">
               <a:rPr lang="en-US" smtClean="0"/>
-              <a:t>4/20/2026</a:t>
+              <a:t>5/10/2026</a:t>
             </a:fld>
             <a:endParaRPr lang="en-US"/>
           </a:p>
@@ -2676,7 +2596,7 @@
           <a:p>
             <a:fld id="{0560A9CD-0304-4E0B-9E82-E7E0115DE05B}" type="datetimeFigureOut">
               <a:rPr lang="en-US" smtClean="0"/>
-              <a:t>4/20/2026</a:t>
+              <a:t>5/10/2026</a:t>
             </a:fld>
             <a:endParaRPr lang="en-US"/>
           </a:p>
@@ -2951,7 +2871,7 @@
           <a:p>
             <a:fld id="{0560A9CD-0304-4E0B-9E82-E7E0115DE05B}" type="datetimeFigureOut">
               <a:rPr lang="en-US" smtClean="0"/>
-              <a:t>4/20/2026</a:t>
+              <a:t>5/10/2026</a:t>
             </a:fld>
             <a:endParaRPr lang="en-US"/>
           </a:p>
@@ -3203,7 +3123,7 @@
           <a:p>
             <a:fld id="{0560A9CD-0304-4E0B-9E82-E7E0115DE05B}" type="datetimeFigureOut">
               <a:rPr lang="en-US" smtClean="0"/>
-              <a:t>4/20/2026</a:t>
+              <a:t>5/10/2026</a:t>
             </a:fld>
             <a:endParaRPr lang="en-US"/>
           </a:p>
@@ -3414,7 +3334,7 @@
           <a:p>
             <a:fld id="{0560A9CD-0304-4E0B-9E82-E7E0115DE05B}" type="datetimeFigureOut">
               <a:rPr lang="en-US" smtClean="0"/>
-              <a:t>4/20/2026</a:t>
+              <a:t>5/10/2026</a:t>
             </a:fld>
             <a:endParaRPr lang="en-US"/>
           </a:p>
@@ -4026,7 +3946,15 @@
           <a:p>
             <a:r>
               <a:rPr lang="en-US" b="1" dirty="0"/>
-              <a:t>5 hours, written exam, with aids, including PC but without internet</a:t>
+              <a:t>5 hours, written exam, with aids, including PC but </a:t>
+            </a:r>
+            <a:r>
+              <a:rPr lang="en-US" b="1" dirty="0">
+                <a:solidFill>
+                  <a:srgbClr val="C00000"/>
+                </a:solidFill>
+              </a:rPr>
+              <a:t>without internet</a:t>
             </a:r>
           </a:p>
           <a:p>

</xml_diff>